<commit_message>
QR code du groupe WhatsApp sur les slides 5 et 184
Encodé en correction d'erreur H, 1960 px, et vérifié par décodage :
le contenu relu correspond au lien, y compris après réduction à 420 px,
ce qui couvre un scan à distance depuis un écran partagé.

Quatre variantes fournies : lien court (recommandé, QR moins dense),
lien complet avec le paramètre mode=gi_t, version à fond transparent,
et panneau blanc prêt à poser.

Les deux slides WhatsApp passent en deux colonnes, QR à gauche et les
quatre lignes de bénéfices à droite, comme dans le deck de septembre.

Co-Authored-By: Claude Opus 5 <noreply@anthropic.com>
Claude-Session: https://claude.ai/code/session_01HFeUWeZDc8HNMSgiuxikf3
</commit_message>
<xml_diff>
--- a/contenus/deck-webinaire/Heritage-Modernite-webinaire.pptx
+++ b/contenus/deck-webinaire/Heritage-Modernite-webinaire.pptx
@@ -23017,16 +23017,40 @@
           </a:prstGeom>
         </p:spPr>
       </p:pic>
-      <p:sp>
-        <p:nvSpPr>
-          <p:cNvPr id="3" name="TextBox 2"/>
+      <p:pic>
+        <p:nvPicPr>
+          <p:cNvPr id="3" name="Picture 2" descr="qr-whatsapp-panneau-blanc.png"/>
+          <p:cNvPicPr>
+            <a:picLocks noChangeAspect="1"/>
+          </p:cNvPicPr>
+          <p:nvPr/>
+        </p:nvPicPr>
+        <p:blipFill>
+          <a:blip r:embed="rId4"/>
+          <a:stretch>
+            <a:fillRect/>
+          </a:stretch>
+        </p:blipFill>
+        <p:spPr>
+          <a:xfrm>
+            <a:off x="812800" y="1460500"/>
+            <a:ext cx="3937000" cy="3937000"/>
+          </a:xfrm>
+          <a:prstGeom prst="rect">
+            <a:avLst/>
+          </a:prstGeom>
+        </p:spPr>
+      </p:pic>
+      <p:sp>
+        <p:nvSpPr>
+          <p:cNvPr id="4" name="TextBox 3"/>
           <p:cNvSpPr txBox="1"/>
           <p:nvPr/>
         </p:nvSpPr>
         <p:spPr>
           <a:xfrm>
-            <a:off x="812800" y="812800"/>
-            <a:ext cx="10566400" cy="5232400"/>
+            <a:off x="5232400" y="1333500"/>
+            <a:ext cx="6146800" cy="952500"/>
           </a:xfrm>
           <a:prstGeom prst="rect">
             <a:avLst/>
@@ -23034,24 +23058,215 @@
           <a:noFill/>
         </p:spPr>
         <p:txBody>
-          <a:bodyPr wrap="square" lIns="0" rIns="0" tIns="0" bIns="0" anchor="ctr">
+          <a:bodyPr wrap="square" lIns="0" rIns="0" tIns="0" bIns="0" anchor="b">
             <a:spAutoFit/>
           </a:bodyPr>
           <a:lstStyle/>
           <a:p>
-            <a:pPr algn="ctr">
-              <a:lnSpc>
-                <a:spcPct val="106000"/>
-              </a:lnSpc>
-            </a:pPr>
-            <a:r>
-              <a:rPr sz="5000" b="1" i="1">
+            <a:pPr algn="l">
+              <a:lnSpc>
+                <a:spcPct val="110000"/>
+              </a:lnSpc>
+            </a:pPr>
+            <a:r>
+              <a:rPr sz="2900" b="1" i="1">
                 <a:solidFill>
                   <a:srgbClr val="FFFFFF"/>
                 </a:solidFill>
                 <a:latin typeface="Archivo"/>
               </a:rPr>
-              <a:t>REJOIGNEZ LE GROUPE WHATSAPP DU LIVE</a:t>
+              <a:t>REJOIGNEZ LE GROUPE</a:t>
+            </a:r>
+          </a:p>
+          <a:p>
+            <a:pPr algn="l">
+              <a:lnSpc>
+                <a:spcPct val="110000"/>
+              </a:lnSpc>
+            </a:pPr>
+            <a:r>
+              <a:rPr sz="2900" b="1" i="1">
+                <a:solidFill>
+                  <a:srgbClr val="FFFFFF"/>
+                </a:solidFill>
+                <a:latin typeface="Archivo"/>
+              </a:rPr>
+              <a:t>WHATSAPP DU LIVE</a:t>
+            </a:r>
+          </a:p>
+        </p:txBody>
+      </p:sp>
+      <p:sp>
+        <p:nvSpPr>
+          <p:cNvPr id="5" name="Rectangle 4"/>
+          <p:cNvSpPr/>
+          <p:nvPr/>
+        </p:nvSpPr>
+        <p:spPr>
+          <a:xfrm>
+            <a:off x="5232400" y="2489200"/>
+            <a:ext cx="1143000" cy="25400"/>
+          </a:xfrm>
+          <a:prstGeom prst="rect">
+            <a:avLst/>
+          </a:prstGeom>
+          <a:solidFill>
+            <a:srgbClr val="E3A94F"/>
+          </a:solidFill>
+          <a:ln>
+            <a:noFill/>
+          </a:ln>
+          <a:effectLst/>
+        </p:spPr>
+        <p:style>
+          <a:lnRef idx="1">
+            <a:schemeClr val="accent1"/>
+          </a:lnRef>
+          <a:fillRef idx="3">
+            <a:schemeClr val="accent1"/>
+          </a:fillRef>
+          <a:effectRef idx="2">
+            <a:schemeClr val="accent1"/>
+          </a:effectRef>
+          <a:fontRef idx="minor">
+            <a:schemeClr val="lt1"/>
+          </a:fontRef>
+        </p:style>
+        <p:txBody>
+          <a:bodyPr rtlCol="0" anchor="ctr"/>
+          <a:lstStyle/>
+          <a:p>
+            <a:pPr algn="ctr"/>
+          </a:p>
+        </p:txBody>
+      </p:sp>
+      <p:sp>
+        <p:nvSpPr>
+          <p:cNvPr id="6" name="TextBox 5"/>
+          <p:cNvSpPr txBox="1"/>
+          <p:nvPr/>
+        </p:nvSpPr>
+        <p:spPr>
+          <a:xfrm>
+            <a:off x="5232400" y="2794000"/>
+            <a:ext cx="6146800" cy="2667000"/>
+          </a:xfrm>
+          <a:prstGeom prst="rect">
+            <a:avLst/>
+          </a:prstGeom>
+          <a:noFill/>
+        </p:spPr>
+        <p:txBody>
+          <a:bodyPr wrap="square" lIns="0" rIns="0" tIns="0" bIns="0" anchor="t">
+            <a:spAutoFit/>
+          </a:bodyPr>
+          <a:lstStyle/>
+          <a:p>
+            <a:pPr algn="l">
+              <a:spcAft>
+                <a:spcPts val="900"/>
+              </a:spcAft>
+            </a:pPr>
+            <a:r>
+              <a:rPr sz="1600" b="0" i="0">
+                <a:solidFill>
+                  <a:srgbClr val="E3A94F"/>
+                </a:solidFill>
+                <a:latin typeface="Poppins"/>
+              </a:rPr>
+              <a:t>C'est là qu'on va :</a:t>
+            </a:r>
+          </a:p>
+          <a:p>
+            <a:pPr algn="l">
+              <a:lnSpc>
+                <a:spcPct val="145000"/>
+              </a:lnSpc>
+              <a:spcAft>
+                <a:spcPts val="600"/>
+              </a:spcAft>
+            </a:pPr>
+            <a:r>
+              <a:rPr sz="1650" b="0" i="0">
+                <a:solidFill>
+                  <a:srgbClr val="FFFFFF"/>
+                </a:solidFill>
+                <a:latin typeface="Poppins"/>
+              </a:rPr>
+              <a:t>🎁 partager des cadeaux exclusifs</a:t>
+            </a:r>
+          </a:p>
+          <a:p>
+            <a:pPr algn="l">
+              <a:lnSpc>
+                <a:spcPct val="145000"/>
+              </a:lnSpc>
+              <a:spcAft>
+                <a:spcPts val="600"/>
+              </a:spcAft>
+            </a:pPr>
+            <a:r>
+              <a:rPr sz="1650" b="0" i="0">
+                <a:solidFill>
+                  <a:srgbClr val="FFFFFF"/>
+                </a:solidFill>
+                <a:latin typeface="Poppins"/>
+              </a:rPr>
+              <a:t>📚 envoyer les ressources mentionnées</a:t>
+            </a:r>
+          </a:p>
+          <a:p>
+            <a:pPr algn="l">
+              <a:lnSpc>
+                <a:spcPct val="145000"/>
+              </a:lnSpc>
+              <a:spcAft>
+                <a:spcPts val="600"/>
+              </a:spcAft>
+            </a:pPr>
+            <a:r>
+              <a:rPr sz="1650" b="0" i="0">
+                <a:solidFill>
+                  <a:srgbClr val="FFFFFF"/>
+                </a:solidFill>
+                <a:latin typeface="Poppins"/>
+              </a:rPr>
+              <a:t>🎯 vous aider à passer à l'action après le webinaire</a:t>
+            </a:r>
+          </a:p>
+          <a:p>
+            <a:pPr algn="l">
+              <a:lnSpc>
+                <a:spcPct val="145000"/>
+              </a:lnSpc>
+              <a:spcAft>
+                <a:spcPts val="600"/>
+              </a:spcAft>
+            </a:pPr>
+            <a:r>
+              <a:rPr sz="1650" b="0" i="0">
+                <a:solidFill>
+                  <a:srgbClr val="FFFFFF"/>
+                </a:solidFill>
+                <a:latin typeface="Poppins"/>
+              </a:rPr>
+              <a:t>🤝 garder le lien avec le Collectif</a:t>
+            </a:r>
+          </a:p>
+          <a:p>
+            <a:pPr algn="l">
+              <a:lnSpc>
+                <a:spcPct val="145000"/>
+              </a:lnSpc>
+            </a:pPr>
+            <a:r>
+              <a:rPr sz="1450" b="0" i="0">
+                <a:solidFill>
+                  <a:srgbClr val="CFCFCF"/>
+                </a:solidFill>
+                <a:latin typeface="Poppins"/>
+              </a:rPr>
+              <a:t>Le webinaire se termine… mais l'accompagnement continue là-bas.</a:t>
             </a:r>
           </a:p>
         </p:txBody>
@@ -28806,16 +29021,40 @@
           </a:prstGeom>
         </p:spPr>
       </p:pic>
-      <p:sp>
-        <p:nvSpPr>
-          <p:cNvPr id="3" name="TextBox 2"/>
+      <p:pic>
+        <p:nvPicPr>
+          <p:cNvPr id="3" name="Picture 2" descr="qr-whatsapp-panneau-blanc.png"/>
+          <p:cNvPicPr>
+            <a:picLocks noChangeAspect="1"/>
+          </p:cNvPicPr>
+          <p:nvPr/>
+        </p:nvPicPr>
+        <p:blipFill>
+          <a:blip r:embed="rId4"/>
+          <a:stretch>
+            <a:fillRect/>
+          </a:stretch>
+        </p:blipFill>
+        <p:spPr>
+          <a:xfrm>
+            <a:off x="812800" y="1460500"/>
+            <a:ext cx="3937000" cy="3937000"/>
+          </a:xfrm>
+          <a:prstGeom prst="rect">
+            <a:avLst/>
+          </a:prstGeom>
+        </p:spPr>
+      </p:pic>
+      <p:sp>
+        <p:nvSpPr>
+          <p:cNvPr id="4" name="TextBox 3"/>
           <p:cNvSpPr txBox="1"/>
           <p:nvPr/>
         </p:nvSpPr>
         <p:spPr>
           <a:xfrm>
-            <a:off x="812800" y="812800"/>
-            <a:ext cx="10566400" cy="698500"/>
+            <a:off x="5232400" y="1333500"/>
+            <a:ext cx="6146800" cy="952500"/>
           </a:xfrm>
           <a:prstGeom prst="rect">
             <a:avLst/>
@@ -28823,37 +29062,53 @@
           <a:noFill/>
         </p:spPr>
         <p:txBody>
-          <a:bodyPr wrap="square" lIns="0" rIns="0" tIns="0" bIns="0" anchor="t">
+          <a:bodyPr wrap="square" lIns="0" rIns="0" tIns="0" bIns="0" anchor="b">
             <a:spAutoFit/>
           </a:bodyPr>
           <a:lstStyle/>
           <a:p>
             <a:pPr algn="l">
               <a:lnSpc>
-                <a:spcPct val="114000"/>
-              </a:lnSpc>
-            </a:pPr>
-            <a:r>
-              <a:rPr sz="2000" b="1" i="1">
+                <a:spcPct val="110000"/>
+              </a:lnSpc>
+            </a:pPr>
+            <a:r>
+              <a:rPr sz="2900" b="1" i="1">
                 <a:solidFill>
                   <a:srgbClr val="FFFFFF"/>
                 </a:solidFill>
                 <a:latin typeface="Archivo"/>
               </a:rPr>
-              <a:t>REJOIGNEZ LE GROUPE WHATSAPP DU LIVE</a:t>
-            </a:r>
-          </a:p>
-        </p:txBody>
-      </p:sp>
-      <p:sp>
-        <p:nvSpPr>
-          <p:cNvPr id="4" name="Rectangle 3"/>
+              <a:t>REJOIGNEZ LE GROUPE</a:t>
+            </a:r>
+          </a:p>
+          <a:p>
+            <a:pPr algn="l">
+              <a:lnSpc>
+                <a:spcPct val="110000"/>
+              </a:lnSpc>
+            </a:pPr>
+            <a:r>
+              <a:rPr sz="2900" b="1" i="1">
+                <a:solidFill>
+                  <a:srgbClr val="FFFFFF"/>
+                </a:solidFill>
+                <a:latin typeface="Archivo"/>
+              </a:rPr>
+              <a:t>WHATSAPP DU LIVE</a:t>
+            </a:r>
+          </a:p>
+        </p:txBody>
+      </p:sp>
+      <p:sp>
+        <p:nvSpPr>
+          <p:cNvPr id="5" name="Rectangle 4"/>
           <p:cNvSpPr/>
           <p:nvPr/>
         </p:nvSpPr>
         <p:spPr>
           <a:xfrm>
-            <a:off x="812800" y="1879600"/>
+            <a:off x="5232400" y="2489200"/>
             <a:ext cx="1143000" cy="25400"/>
           </a:xfrm>
           <a:prstGeom prst="rect">
@@ -28891,14 +29146,14 @@
       </p:sp>
       <p:sp>
         <p:nvSpPr>
-          <p:cNvPr id="5" name="TextBox 4"/>
+          <p:cNvPr id="6" name="TextBox 5"/>
           <p:cNvSpPr txBox="1"/>
           <p:nvPr/>
         </p:nvSpPr>
         <p:spPr>
           <a:xfrm>
-            <a:off x="812800" y="2222500"/>
-            <a:ext cx="10566400" cy="3822700"/>
+            <a:off x="5232400" y="2794000"/>
+            <a:ext cx="6146800" cy="2667000"/>
           </a:xfrm>
           <a:prstGeom prst="rect">
             <a:avLst/>
@@ -28912,15 +29167,31 @@
           <a:lstStyle/>
           <a:p>
             <a:pPr algn="l">
-              <a:lnSpc>
-                <a:spcPct val="142000"/>
-              </a:lnSpc>
               <a:spcAft>
                 <a:spcPts val="900"/>
               </a:spcAft>
             </a:pPr>
             <a:r>
-              <a:rPr sz="1850" b="0" i="0">
+              <a:rPr sz="1600" b="0" i="0">
+                <a:solidFill>
+                  <a:srgbClr val="E3A94F"/>
+                </a:solidFill>
+                <a:latin typeface="Poppins"/>
+              </a:rPr>
+              <a:t>C'est là qu'on va :</a:t>
+            </a:r>
+          </a:p>
+          <a:p>
+            <a:pPr algn="l">
+              <a:lnSpc>
+                <a:spcPct val="145000"/>
+              </a:lnSpc>
+              <a:spcAft>
+                <a:spcPts val="600"/>
+              </a:spcAft>
+            </a:pPr>
+            <a:r>
+              <a:rPr sz="1650" b="0" i="0">
                 <a:solidFill>
                   <a:srgbClr val="FFFFFF"/>
                 </a:solidFill>
@@ -28932,14 +29203,14 @@
           <a:p>
             <a:pPr algn="l">
               <a:lnSpc>
-                <a:spcPct val="142000"/>
-              </a:lnSpc>
-              <a:spcAft>
-                <a:spcPts val="900"/>
-              </a:spcAft>
-            </a:pPr>
-            <a:r>
-              <a:rPr sz="1850" b="0" i="0">
+                <a:spcPct val="145000"/>
+              </a:lnSpc>
+              <a:spcAft>
+                <a:spcPts val="600"/>
+              </a:spcAft>
+            </a:pPr>
+            <a:r>
+              <a:rPr sz="1650" b="0" i="0">
                 <a:solidFill>
                   <a:srgbClr val="FFFFFF"/>
                 </a:solidFill>
@@ -28951,14 +29222,14 @@
           <a:p>
             <a:pPr algn="l">
               <a:lnSpc>
-                <a:spcPct val="142000"/>
-              </a:lnSpc>
-              <a:spcAft>
-                <a:spcPts val="900"/>
-              </a:spcAft>
-            </a:pPr>
-            <a:r>
-              <a:rPr sz="1850" b="0" i="0">
+                <a:spcPct val="145000"/>
+              </a:lnSpc>
+              <a:spcAft>
+                <a:spcPts val="600"/>
+              </a:spcAft>
+            </a:pPr>
+            <a:r>
+              <a:rPr sz="1650" b="0" i="0">
                 <a:solidFill>
                   <a:srgbClr val="FFFFFF"/>
                 </a:solidFill>
@@ -28970,20 +29241,36 @@
           <a:p>
             <a:pPr algn="l">
               <a:lnSpc>
-                <a:spcPct val="142000"/>
-              </a:lnSpc>
-              <a:spcAft>
-                <a:spcPts val="900"/>
-              </a:spcAft>
-            </a:pPr>
-            <a:r>
-              <a:rPr sz="1850" b="0" i="0">
+                <a:spcPct val="145000"/>
+              </a:lnSpc>
+              <a:spcAft>
+                <a:spcPts val="600"/>
+              </a:spcAft>
+            </a:pPr>
+            <a:r>
+              <a:rPr sz="1650" b="0" i="0">
                 <a:solidFill>
                   <a:srgbClr val="FFFFFF"/>
                 </a:solidFill>
                 <a:latin typeface="Poppins"/>
               </a:rPr>
               <a:t>🤝 garder le lien avec le Collectif</a:t>
+            </a:r>
+          </a:p>
+          <a:p>
+            <a:pPr algn="l">
+              <a:lnSpc>
+                <a:spcPct val="145000"/>
+              </a:lnSpc>
+            </a:pPr>
+            <a:r>
+              <a:rPr sz="1450" b="0" i="0">
+                <a:solidFill>
+                  <a:srgbClr val="CFCFCF"/>
+                </a:solidFill>
+                <a:latin typeface="Poppins"/>
+              </a:rPr>
+              <a:t>Le webinaire se termine… mais l'accompagnement continue là-bas.</a:t>
             </a:r>
           </a:p>
         </p:txBody>

</xml_diff>